<commit_message>
adding doc and ppt files
</commit_message>
<xml_diff>
--- a/Cost_Optimization.pptx
+++ b/Cost_Optimization.pptx
@@ -264,7 +264,7 @@
           <a:p>
             <a:fld id="{5DBCD078-A1DE-4913-9B4A-9FAFF04AE4C7}" type="datetimeFigureOut">
               <a:rPr lang="en-IN" smtClean="0"/>
-              <a:t>06-08-2025</a:t>
+              <a:t>09-08-2025</a:t>
             </a:fld>
             <a:endParaRPr lang="en-IN"/>
           </a:p>
@@ -464,7 +464,7 @@
           <a:p>
             <a:fld id="{5DBCD078-A1DE-4913-9B4A-9FAFF04AE4C7}" type="datetimeFigureOut">
               <a:rPr lang="en-IN" smtClean="0"/>
-              <a:t>06-08-2025</a:t>
+              <a:t>09-08-2025</a:t>
             </a:fld>
             <a:endParaRPr lang="en-IN"/>
           </a:p>
@@ -674,7 +674,7 @@
           <a:p>
             <a:fld id="{5DBCD078-A1DE-4913-9B4A-9FAFF04AE4C7}" type="datetimeFigureOut">
               <a:rPr lang="en-IN" smtClean="0"/>
-              <a:t>06-08-2025</a:t>
+              <a:t>09-08-2025</a:t>
             </a:fld>
             <a:endParaRPr lang="en-IN"/>
           </a:p>
@@ -874,7 +874,7 @@
           <a:p>
             <a:fld id="{5DBCD078-A1DE-4913-9B4A-9FAFF04AE4C7}" type="datetimeFigureOut">
               <a:rPr lang="en-IN" smtClean="0"/>
-              <a:t>06-08-2025</a:t>
+              <a:t>09-08-2025</a:t>
             </a:fld>
             <a:endParaRPr lang="en-IN"/>
           </a:p>
@@ -1150,7 +1150,7 @@
           <a:p>
             <a:fld id="{5DBCD078-A1DE-4913-9B4A-9FAFF04AE4C7}" type="datetimeFigureOut">
               <a:rPr lang="en-IN" smtClean="0"/>
-              <a:t>06-08-2025</a:t>
+              <a:t>09-08-2025</a:t>
             </a:fld>
             <a:endParaRPr lang="en-IN"/>
           </a:p>
@@ -1418,7 +1418,7 @@
           <a:p>
             <a:fld id="{5DBCD078-A1DE-4913-9B4A-9FAFF04AE4C7}" type="datetimeFigureOut">
               <a:rPr lang="en-IN" smtClean="0"/>
-              <a:t>06-08-2025</a:t>
+              <a:t>09-08-2025</a:t>
             </a:fld>
             <a:endParaRPr lang="en-IN"/>
           </a:p>
@@ -1833,7 +1833,7 @@
           <a:p>
             <a:fld id="{5DBCD078-A1DE-4913-9B4A-9FAFF04AE4C7}" type="datetimeFigureOut">
               <a:rPr lang="en-IN" smtClean="0"/>
-              <a:t>06-08-2025</a:t>
+              <a:t>09-08-2025</a:t>
             </a:fld>
             <a:endParaRPr lang="en-IN"/>
           </a:p>
@@ -1975,7 +1975,7 @@
           <a:p>
             <a:fld id="{5DBCD078-A1DE-4913-9B4A-9FAFF04AE4C7}" type="datetimeFigureOut">
               <a:rPr lang="en-IN" smtClean="0"/>
-              <a:t>06-08-2025</a:t>
+              <a:t>09-08-2025</a:t>
             </a:fld>
             <a:endParaRPr lang="en-IN"/>
           </a:p>
@@ -2088,7 +2088,7 @@
           <a:p>
             <a:fld id="{5DBCD078-A1DE-4913-9B4A-9FAFF04AE4C7}" type="datetimeFigureOut">
               <a:rPr lang="en-IN" smtClean="0"/>
-              <a:t>06-08-2025</a:t>
+              <a:t>09-08-2025</a:t>
             </a:fld>
             <a:endParaRPr lang="en-IN"/>
           </a:p>
@@ -2401,7 +2401,7 @@
           <a:p>
             <a:fld id="{5DBCD078-A1DE-4913-9B4A-9FAFF04AE4C7}" type="datetimeFigureOut">
               <a:rPr lang="en-IN" smtClean="0"/>
-              <a:t>06-08-2025</a:t>
+              <a:t>09-08-2025</a:t>
             </a:fld>
             <a:endParaRPr lang="en-IN"/>
           </a:p>
@@ -2690,7 +2690,7 @@
           <a:p>
             <a:fld id="{5DBCD078-A1DE-4913-9B4A-9FAFF04AE4C7}" type="datetimeFigureOut">
               <a:rPr lang="en-IN" smtClean="0"/>
-              <a:t>06-08-2025</a:t>
+              <a:t>09-08-2025</a:t>
             </a:fld>
             <a:endParaRPr lang="en-IN"/>
           </a:p>
@@ -2933,7 +2933,7 @@
           <a:p>
             <a:fld id="{5DBCD078-A1DE-4913-9B4A-9FAFF04AE4C7}" type="datetimeFigureOut">
               <a:rPr lang="en-IN" smtClean="0"/>
-              <a:t>06-08-2025</a:t>
+              <a:t>09-08-2025</a:t>
             </a:fld>
             <a:endParaRPr lang="en-IN"/>
           </a:p>

</xml_diff>

<commit_message>
changes in doc and ppt
</commit_message>
<xml_diff>
--- a/Cost_Optimization.pptx
+++ b/Cost_Optimization.pptx
@@ -9,6 +9,9 @@
     <p:sldId id="257" r:id="rId3"/>
     <p:sldId id="258" r:id="rId4"/>
     <p:sldId id="259" r:id="rId5"/>
+    <p:sldId id="260" r:id="rId6"/>
+    <p:sldId id="262" r:id="rId7"/>
+    <p:sldId id="261" r:id="rId8"/>
   </p:sldIdLst>
   <p:sldSz cx="12192000" cy="6858000"/>
   <p:notesSz cx="6858000" cy="9144000"/>
@@ -264,7 +267,7 @@
           <a:p>
             <a:fld id="{5DBCD078-A1DE-4913-9B4A-9FAFF04AE4C7}" type="datetimeFigureOut">
               <a:rPr lang="en-IN" smtClean="0"/>
-              <a:t>09-08-2025</a:t>
+              <a:t>12-08-2025</a:t>
             </a:fld>
             <a:endParaRPr lang="en-IN"/>
           </a:p>
@@ -464,7 +467,7 @@
           <a:p>
             <a:fld id="{5DBCD078-A1DE-4913-9B4A-9FAFF04AE4C7}" type="datetimeFigureOut">
               <a:rPr lang="en-IN" smtClean="0"/>
-              <a:t>09-08-2025</a:t>
+              <a:t>12-08-2025</a:t>
             </a:fld>
             <a:endParaRPr lang="en-IN"/>
           </a:p>
@@ -674,7 +677,7 @@
           <a:p>
             <a:fld id="{5DBCD078-A1DE-4913-9B4A-9FAFF04AE4C7}" type="datetimeFigureOut">
               <a:rPr lang="en-IN" smtClean="0"/>
-              <a:t>09-08-2025</a:t>
+              <a:t>12-08-2025</a:t>
             </a:fld>
             <a:endParaRPr lang="en-IN"/>
           </a:p>
@@ -874,7 +877,7 @@
           <a:p>
             <a:fld id="{5DBCD078-A1DE-4913-9B4A-9FAFF04AE4C7}" type="datetimeFigureOut">
               <a:rPr lang="en-IN" smtClean="0"/>
-              <a:t>09-08-2025</a:t>
+              <a:t>12-08-2025</a:t>
             </a:fld>
             <a:endParaRPr lang="en-IN"/>
           </a:p>
@@ -1150,7 +1153,7 @@
           <a:p>
             <a:fld id="{5DBCD078-A1DE-4913-9B4A-9FAFF04AE4C7}" type="datetimeFigureOut">
               <a:rPr lang="en-IN" smtClean="0"/>
-              <a:t>09-08-2025</a:t>
+              <a:t>12-08-2025</a:t>
             </a:fld>
             <a:endParaRPr lang="en-IN"/>
           </a:p>
@@ -1418,7 +1421,7 @@
           <a:p>
             <a:fld id="{5DBCD078-A1DE-4913-9B4A-9FAFF04AE4C7}" type="datetimeFigureOut">
               <a:rPr lang="en-IN" smtClean="0"/>
-              <a:t>09-08-2025</a:t>
+              <a:t>12-08-2025</a:t>
             </a:fld>
             <a:endParaRPr lang="en-IN"/>
           </a:p>
@@ -1833,7 +1836,7 @@
           <a:p>
             <a:fld id="{5DBCD078-A1DE-4913-9B4A-9FAFF04AE4C7}" type="datetimeFigureOut">
               <a:rPr lang="en-IN" smtClean="0"/>
-              <a:t>09-08-2025</a:t>
+              <a:t>12-08-2025</a:t>
             </a:fld>
             <a:endParaRPr lang="en-IN"/>
           </a:p>
@@ -1975,7 +1978,7 @@
           <a:p>
             <a:fld id="{5DBCD078-A1DE-4913-9B4A-9FAFF04AE4C7}" type="datetimeFigureOut">
               <a:rPr lang="en-IN" smtClean="0"/>
-              <a:t>09-08-2025</a:t>
+              <a:t>12-08-2025</a:t>
             </a:fld>
             <a:endParaRPr lang="en-IN"/>
           </a:p>
@@ -2088,7 +2091,7 @@
           <a:p>
             <a:fld id="{5DBCD078-A1DE-4913-9B4A-9FAFF04AE4C7}" type="datetimeFigureOut">
               <a:rPr lang="en-IN" smtClean="0"/>
-              <a:t>09-08-2025</a:t>
+              <a:t>12-08-2025</a:t>
             </a:fld>
             <a:endParaRPr lang="en-IN"/>
           </a:p>
@@ -2401,7 +2404,7 @@
           <a:p>
             <a:fld id="{5DBCD078-A1DE-4913-9B4A-9FAFF04AE4C7}" type="datetimeFigureOut">
               <a:rPr lang="en-IN" smtClean="0"/>
-              <a:t>09-08-2025</a:t>
+              <a:t>12-08-2025</a:t>
             </a:fld>
             <a:endParaRPr lang="en-IN"/>
           </a:p>
@@ -2690,7 +2693,7 @@
           <a:p>
             <a:fld id="{5DBCD078-A1DE-4913-9B4A-9FAFF04AE4C7}" type="datetimeFigureOut">
               <a:rPr lang="en-IN" smtClean="0"/>
-              <a:t>09-08-2025</a:t>
+              <a:t>12-08-2025</a:t>
             </a:fld>
             <a:endParaRPr lang="en-IN"/>
           </a:p>
@@ -2933,7 +2936,7 @@
           <a:p>
             <a:fld id="{5DBCD078-A1DE-4913-9B4A-9FAFF04AE4C7}" type="datetimeFigureOut">
               <a:rPr lang="en-IN" smtClean="0"/>
-              <a:t>09-08-2025</a:t>
+              <a:t>12-08-2025</a:t>
             </a:fld>
             <a:endParaRPr lang="en-IN"/>
           </a:p>
@@ -6357,6 +6360,1531 @@
 </p:sld>
 </file>
 
+<file path=ppt/slides/slide5.xml><?xml version="1.0" encoding="utf-8"?>
+<p:sld xmlns:a="http://schemas.openxmlformats.org/drawingml/2006/main" xmlns:r="http://schemas.openxmlformats.org/officeDocument/2006/relationships" xmlns:p="http://schemas.openxmlformats.org/presentationml/2006/main">
+  <p:cSld>
+    <p:spTree>
+      <p:nvGrpSpPr>
+        <p:cNvPr id="1" name="">
+          <a:extLst>
+            <a:ext uri="{FF2B5EF4-FFF2-40B4-BE49-F238E27FC236}">
+              <a16:creationId xmlns:a16="http://schemas.microsoft.com/office/drawing/2014/main" id="{F3767F10-BF67-44D2-F961-E2D9EE32C607}"/>
+            </a:ext>
+          </a:extLst>
+        </p:cNvPr>
+        <p:cNvGrpSpPr/>
+        <p:nvPr/>
+      </p:nvGrpSpPr>
+      <p:grpSpPr>
+        <a:xfrm>
+          <a:off x="0" y="0"/>
+          <a:ext cx="0" cy="0"/>
+          <a:chOff x="0" y="0"/>
+          <a:chExt cx="0" cy="0"/>
+        </a:xfrm>
+      </p:grpSpPr>
+      <p:sp>
+        <p:nvSpPr>
+          <p:cNvPr id="2" name="Title 1">
+            <a:extLst>
+              <a:ext uri="{FF2B5EF4-FFF2-40B4-BE49-F238E27FC236}">
+                <a16:creationId xmlns:a16="http://schemas.microsoft.com/office/drawing/2014/main" id="{96ED7D51-355A-46D7-D583-CF04FA271CD2}"/>
+              </a:ext>
+            </a:extLst>
+          </p:cNvPr>
+          <p:cNvSpPr>
+            <a:spLocks noGrp="1"/>
+          </p:cNvSpPr>
+          <p:nvPr>
+            <p:ph type="title"/>
+          </p:nvPr>
+        </p:nvSpPr>
+        <p:spPr>
+          <a:xfrm>
+            <a:off x="765048" y="376393"/>
+            <a:ext cx="10515600" cy="348107"/>
+          </a:xfrm>
+        </p:spPr>
+        <p:txBody>
+          <a:bodyPr>
+            <a:normAutofit/>
+          </a:bodyPr>
+          <a:lstStyle/>
+          <a:p>
+            <a:r>
+              <a:rPr lang="en-IN" sz="1800" b="1" dirty="0">
+                <a:latin typeface="+mn-lt"/>
+              </a:rPr>
+              <a:t>GCP services cost optimization use cases with example</a:t>
+            </a:r>
+          </a:p>
+        </p:txBody>
+      </p:sp>
+      <p:graphicFrame>
+        <p:nvGraphicFramePr>
+          <p:cNvPr id="6" name="Content Placeholder 5">
+            <a:extLst>
+              <a:ext uri="{FF2B5EF4-FFF2-40B4-BE49-F238E27FC236}">
+                <a16:creationId xmlns:a16="http://schemas.microsoft.com/office/drawing/2014/main" id="{0D6EAC3B-19F7-4EBF-F9EA-E07F364F270A}"/>
+              </a:ext>
+            </a:extLst>
+          </p:cNvPr>
+          <p:cNvGraphicFramePr>
+            <a:graphicFrameLocks noGrp="1"/>
+          </p:cNvGraphicFramePr>
+          <p:nvPr>
+            <p:ph idx="1"/>
+            <p:extLst>
+              <p:ext uri="{D42A27DB-BD31-4B8C-83A1-F6EECF244321}">
+                <p14:modId xmlns:p14="http://schemas.microsoft.com/office/powerpoint/2010/main" val="3595290516"/>
+              </p:ext>
+            </p:extLst>
+          </p:nvPr>
+        </p:nvGraphicFramePr>
+        <p:xfrm>
+          <a:off x="804672" y="827567"/>
+          <a:ext cx="10582655" cy="5654040"/>
+        </p:xfrm>
+        <a:graphic>
+          <a:graphicData uri="http://schemas.openxmlformats.org/drawingml/2006/table">
+            <a:tbl>
+              <a:tblPr firstRow="1" bandRow="1">
+                <a:tableStyleId>{5C22544A-7EE6-4342-B048-85BDC9FD1C3A}</a:tableStyleId>
+              </a:tblPr>
+              <a:tblGrid>
+                <a:gridCol w="2116531">
+                  <a:extLst>
+                    <a:ext uri="{9D8B030D-6E8A-4147-A177-3AD203B41FA5}">
+                      <a16:colId xmlns:a16="http://schemas.microsoft.com/office/drawing/2014/main" val="3960887689"/>
+                    </a:ext>
+                  </a:extLst>
+                </a:gridCol>
+                <a:gridCol w="2116531">
+                  <a:extLst>
+                    <a:ext uri="{9D8B030D-6E8A-4147-A177-3AD203B41FA5}">
+                      <a16:colId xmlns:a16="http://schemas.microsoft.com/office/drawing/2014/main" val="739127273"/>
+                    </a:ext>
+                  </a:extLst>
+                </a:gridCol>
+                <a:gridCol w="2116531">
+                  <a:extLst>
+                    <a:ext uri="{9D8B030D-6E8A-4147-A177-3AD203B41FA5}">
+                      <a16:colId xmlns:a16="http://schemas.microsoft.com/office/drawing/2014/main" val="1537214704"/>
+                    </a:ext>
+                  </a:extLst>
+                </a:gridCol>
+                <a:gridCol w="2116531">
+                  <a:extLst>
+                    <a:ext uri="{9D8B030D-6E8A-4147-A177-3AD203B41FA5}">
+                      <a16:colId xmlns:a16="http://schemas.microsoft.com/office/drawing/2014/main" val="3492142327"/>
+                    </a:ext>
+                  </a:extLst>
+                </a:gridCol>
+                <a:gridCol w="2116531">
+                  <a:extLst>
+                    <a:ext uri="{9D8B030D-6E8A-4147-A177-3AD203B41FA5}">
+                      <a16:colId xmlns:a16="http://schemas.microsoft.com/office/drawing/2014/main" val="3459181092"/>
+                    </a:ext>
+                  </a:extLst>
+                </a:gridCol>
+              </a:tblGrid>
+              <a:tr h="370840">
+                <a:tc>
+                  <a:txBody>
+                    <a:bodyPr/>
+                    <a:lstStyle/>
+                    <a:p>
+                      <a:pPr>
+                        <a:buNone/>
+                      </a:pPr>
+                      <a:r>
+                        <a:rPr lang="en-IN" sz="1100" b="1">
+                          <a:solidFill>
+                            <a:srgbClr val="000000"/>
+                          </a:solidFill>
+                          <a:effectLst/>
+                          <a:latin typeface="+mn-lt"/>
+                        </a:rPr>
+                        <a:t>GCP Service</a:t>
+                      </a:r>
+                    </a:p>
+                  </a:txBody>
+                  <a:tcPr anchor="ctr"/>
+                </a:tc>
+                <a:tc>
+                  <a:txBody>
+                    <a:bodyPr/>
+                    <a:lstStyle/>
+                    <a:p>
+                      <a:pPr>
+                        <a:buNone/>
+                      </a:pPr>
+                      <a:r>
+                        <a:rPr lang="en-US" sz="1100" b="1">
+                          <a:solidFill>
+                            <a:srgbClr val="000000"/>
+                          </a:solidFill>
+                          <a:effectLst/>
+                          <a:latin typeface="+mn-lt"/>
+                        </a:rPr>
+                        <a:t>Cost Optimization Use Case Example</a:t>
+                      </a:r>
+                    </a:p>
+                  </a:txBody>
+                  <a:tcPr anchor="ctr"/>
+                </a:tc>
+                <a:tc>
+                  <a:txBody>
+                    <a:bodyPr/>
+                    <a:lstStyle/>
+                    <a:p>
+                      <a:pPr>
+                        <a:buNone/>
+                      </a:pPr>
+                      <a:r>
+                        <a:rPr lang="en-IN" sz="1100" b="1">
+                          <a:solidFill>
+                            <a:srgbClr val="000000"/>
+                          </a:solidFill>
+                          <a:effectLst/>
+                          <a:latin typeface="+mn-lt"/>
+                        </a:rPr>
+                        <a:t>Problem Type</a:t>
+                      </a:r>
+                    </a:p>
+                  </a:txBody>
+                  <a:tcPr anchor="ctr"/>
+                </a:tc>
+                <a:tc>
+                  <a:txBody>
+                    <a:bodyPr/>
+                    <a:lstStyle/>
+                    <a:p>
+                      <a:pPr>
+                        <a:buNone/>
+                      </a:pPr>
+                      <a:r>
+                        <a:rPr lang="en-IN" sz="1100" b="1">
+                          <a:solidFill>
+                            <a:srgbClr val="000000"/>
+                          </a:solidFill>
+                          <a:effectLst/>
+                          <a:latin typeface="+mn-lt"/>
+                        </a:rPr>
+                        <a:t>Solver</a:t>
+                      </a:r>
+                    </a:p>
+                  </a:txBody>
+                  <a:tcPr anchor="ctr"/>
+                </a:tc>
+                <a:tc>
+                  <a:txBody>
+                    <a:bodyPr/>
+                    <a:lstStyle/>
+                    <a:p>
+                      <a:pPr>
+                        <a:buNone/>
+                      </a:pPr>
+                      <a:r>
+                        <a:rPr lang="en-IN" sz="1100" b="1">
+                          <a:solidFill>
+                            <a:srgbClr val="000000"/>
+                          </a:solidFill>
+                          <a:effectLst/>
+                          <a:latin typeface="+mn-lt"/>
+                        </a:rPr>
+                        <a:t>Optimization Justification</a:t>
+                      </a:r>
+                    </a:p>
+                  </a:txBody>
+                  <a:tcPr anchor="ctr"/>
+                </a:tc>
+                <a:extLst>
+                  <a:ext uri="{0D108BD9-81ED-4DB2-BD59-A6C34878D82A}">
+                    <a16:rowId xmlns:a16="http://schemas.microsoft.com/office/drawing/2014/main" val="1963196394"/>
+                  </a:ext>
+                </a:extLst>
+              </a:tr>
+              <a:tr h="370840">
+                <a:tc>
+                  <a:txBody>
+                    <a:bodyPr/>
+                    <a:lstStyle/>
+                    <a:p>
+                      <a:pPr>
+                        <a:buNone/>
+                      </a:pPr>
+                      <a:r>
+                        <a:rPr lang="en-IN" sz="1100" dirty="0">
+                          <a:solidFill>
+                            <a:srgbClr val="000000"/>
+                          </a:solidFill>
+                          <a:effectLst/>
+                          <a:latin typeface="+mn-lt"/>
+                        </a:rPr>
+                        <a:t>Cloud Storage</a:t>
+                      </a:r>
+                    </a:p>
+                  </a:txBody>
+                  <a:tcPr anchor="ctr"/>
+                </a:tc>
+                <a:tc>
+                  <a:txBody>
+                    <a:bodyPr/>
+                    <a:lstStyle/>
+                    <a:p>
+                      <a:pPr>
+                        <a:buNone/>
+                      </a:pPr>
+                      <a:r>
+                        <a:rPr lang="en-US" sz="1100">
+                          <a:solidFill>
+                            <a:srgbClr val="000000"/>
+                          </a:solidFill>
+                          <a:effectLst/>
+                          <a:latin typeface="+mn-lt"/>
+                        </a:rPr>
+                        <a:t>Assign data objects to storage classes (Standard, Nearline, Coldline, Archive) based on access frequency and retention period to minimize storage, retrieval, and egress costs.</a:t>
+                      </a:r>
+                    </a:p>
+                  </a:txBody>
+                  <a:tcPr anchor="ctr"/>
+                </a:tc>
+                <a:tc>
+                  <a:txBody>
+                    <a:bodyPr/>
+                    <a:lstStyle/>
+                    <a:p>
+                      <a:pPr>
+                        <a:buNone/>
+                      </a:pPr>
+                      <a:r>
+                        <a:rPr lang="en-IN" sz="1100">
+                          <a:solidFill>
+                            <a:srgbClr val="000000"/>
+                          </a:solidFill>
+                          <a:effectLst/>
+                          <a:latin typeface="+mn-lt"/>
+                        </a:rPr>
+                        <a:t>Mixed-Integer Programming (MIP)</a:t>
+                      </a:r>
+                    </a:p>
+                  </a:txBody>
+                  <a:tcPr anchor="ctr"/>
+                </a:tc>
+                <a:tc>
+                  <a:txBody>
+                    <a:bodyPr/>
+                    <a:lstStyle/>
+                    <a:p>
+                      <a:pPr>
+                        <a:buNone/>
+                      </a:pPr>
+                      <a:r>
+                        <a:rPr lang="en-IN" sz="1100">
+                          <a:solidFill>
+                            <a:srgbClr val="000000"/>
+                          </a:solidFill>
+                          <a:effectLst/>
+                          <a:latin typeface="+mn-lt"/>
+                        </a:rPr>
+                        <a:t>OR-Tools (SCIP)</a:t>
+                      </a:r>
+                    </a:p>
+                  </a:txBody>
+                  <a:tcPr anchor="ctr"/>
+                </a:tc>
+                <a:tc>
+                  <a:txBody>
+                    <a:bodyPr/>
+                    <a:lstStyle/>
+                    <a:p>
+                      <a:pPr>
+                        <a:buNone/>
+                      </a:pPr>
+                      <a:r>
+                        <a:rPr lang="en-US" sz="1100">
+                          <a:solidFill>
+                            <a:srgbClr val="000000"/>
+                          </a:solidFill>
+                          <a:effectLst/>
+                          <a:latin typeface="+mn-lt"/>
+                        </a:rPr>
+                        <a:t>Reduces costs by selecting cheaper storage classes (e.g., Archive at $0.0022/GB vs. Standard at $0.023/GB) for infrequently accessed data, respecting minimum storage durations and access patterns.</a:t>
+                      </a:r>
+                    </a:p>
+                  </a:txBody>
+                  <a:tcPr anchor="ctr"/>
+                </a:tc>
+                <a:extLst>
+                  <a:ext uri="{0D108BD9-81ED-4DB2-BD59-A6C34878D82A}">
+                    <a16:rowId xmlns:a16="http://schemas.microsoft.com/office/drawing/2014/main" val="1904820983"/>
+                  </a:ext>
+                </a:extLst>
+              </a:tr>
+              <a:tr h="370840">
+                <a:tc>
+                  <a:txBody>
+                    <a:bodyPr/>
+                    <a:lstStyle/>
+                    <a:p>
+                      <a:pPr>
+                        <a:buNone/>
+                      </a:pPr>
+                      <a:r>
+                        <a:rPr lang="en-IN" sz="1100">
+                          <a:solidFill>
+                            <a:srgbClr val="000000"/>
+                          </a:solidFill>
+                          <a:effectLst/>
+                          <a:latin typeface="+mn-lt"/>
+                        </a:rPr>
+                        <a:t>BigQuery</a:t>
+                      </a:r>
+                    </a:p>
+                  </a:txBody>
+                  <a:tcPr anchor="ctr"/>
+                </a:tc>
+                <a:tc>
+                  <a:txBody>
+                    <a:bodyPr/>
+                    <a:lstStyle/>
+                    <a:p>
+                      <a:pPr>
+                        <a:buNone/>
+                      </a:pPr>
+                      <a:r>
+                        <a:rPr lang="en-US" sz="1100">
+                          <a:solidFill>
+                            <a:srgbClr val="000000"/>
+                          </a:solidFill>
+                          <a:effectLst/>
+                          <a:latin typeface="+mn-lt"/>
+                        </a:rPr>
+                        <a:t>Optimize dataset storage (active vs. long-term) and query pricing (on-demand vs. flat-rate slots) to minimize storage and query processing costs.</a:t>
+                      </a:r>
+                    </a:p>
+                  </a:txBody>
+                  <a:tcPr anchor="ctr"/>
+                </a:tc>
+                <a:tc>
+                  <a:txBody>
+                    <a:bodyPr/>
+                    <a:lstStyle/>
+                    <a:p>
+                      <a:pPr>
+                        <a:buNone/>
+                      </a:pPr>
+                      <a:r>
+                        <a:rPr lang="en-IN" sz="1100" dirty="0">
+                          <a:solidFill>
+                            <a:srgbClr val="000000"/>
+                          </a:solidFill>
+                          <a:effectLst/>
+                          <a:latin typeface="+mn-lt"/>
+                        </a:rPr>
+                        <a:t>Mixed-Integer Programming (MIP)</a:t>
+                      </a:r>
+                    </a:p>
+                  </a:txBody>
+                  <a:tcPr anchor="ctr"/>
+                </a:tc>
+                <a:tc>
+                  <a:txBody>
+                    <a:bodyPr/>
+                    <a:lstStyle/>
+                    <a:p>
+                      <a:pPr>
+                        <a:buNone/>
+                      </a:pPr>
+                      <a:r>
+                        <a:rPr lang="en-IN" sz="1100">
+                          <a:solidFill>
+                            <a:srgbClr val="000000"/>
+                          </a:solidFill>
+                          <a:effectLst/>
+                          <a:latin typeface="+mn-lt"/>
+                        </a:rPr>
+                        <a:t>OR-Tools (SCIP)</a:t>
+                      </a:r>
+                    </a:p>
+                  </a:txBody>
+                  <a:tcPr anchor="ctr"/>
+                </a:tc>
+                <a:tc>
+                  <a:txBody>
+                    <a:bodyPr/>
+                    <a:lstStyle/>
+                    <a:p>
+                      <a:pPr>
+                        <a:buNone/>
+                      </a:pPr>
+                      <a:r>
+                        <a:rPr lang="en-US" sz="1100">
+                          <a:solidFill>
+                            <a:srgbClr val="000000"/>
+                          </a:solidFill>
+                          <a:effectLst/>
+                          <a:latin typeface="+mn-lt"/>
+                        </a:rPr>
+                        <a:t>Lowers costs by using long-term storage ($0.01/GB vs. $0.02/GB) for unmodified data and choosing flat-rate slots ($20/slot/month) for high query volumes, balancing free tiers (10 GB storage, 1 TB queries).</a:t>
+                      </a:r>
+                    </a:p>
+                  </a:txBody>
+                  <a:tcPr anchor="ctr"/>
+                </a:tc>
+                <a:extLst>
+                  <a:ext uri="{0D108BD9-81ED-4DB2-BD59-A6C34878D82A}">
+                    <a16:rowId xmlns:a16="http://schemas.microsoft.com/office/drawing/2014/main" val="3933942296"/>
+                  </a:ext>
+                </a:extLst>
+              </a:tr>
+              <a:tr h="370840">
+                <a:tc>
+                  <a:txBody>
+                    <a:bodyPr/>
+                    <a:lstStyle/>
+                    <a:p>
+                      <a:pPr>
+                        <a:buNone/>
+                      </a:pPr>
+                      <a:r>
+                        <a:rPr lang="en-IN" sz="1100">
+                          <a:solidFill>
+                            <a:srgbClr val="000000"/>
+                          </a:solidFill>
+                          <a:effectLst/>
+                          <a:latin typeface="+mn-lt"/>
+                        </a:rPr>
+                        <a:t>Google Kubernetes Engine (GKE)</a:t>
+                      </a:r>
+                    </a:p>
+                  </a:txBody>
+                  <a:tcPr anchor="ctr"/>
+                </a:tc>
+                <a:tc>
+                  <a:txBody>
+                    <a:bodyPr/>
+                    <a:lstStyle/>
+                    <a:p>
+                      <a:pPr>
+                        <a:buNone/>
+                      </a:pPr>
+                      <a:r>
+                        <a:rPr lang="en-US" sz="1100">
+                          <a:solidFill>
+                            <a:srgbClr val="000000"/>
+                          </a:solidFill>
+                          <a:effectLst/>
+                          <a:latin typeface="+mn-lt"/>
+                        </a:rPr>
+                        <a:t>Allocate workloads to node pools with optimal machine types and preemptible VMs, balancing performance and cost while meeting resource demands.</a:t>
+                      </a:r>
+                    </a:p>
+                  </a:txBody>
+                  <a:tcPr anchor="ctr"/>
+                </a:tc>
+                <a:tc>
+                  <a:txBody>
+                    <a:bodyPr/>
+                    <a:lstStyle/>
+                    <a:p>
+                      <a:pPr>
+                        <a:buNone/>
+                      </a:pPr>
+                      <a:r>
+                        <a:rPr lang="en-US" sz="1100">
+                          <a:solidFill>
+                            <a:srgbClr val="000000"/>
+                          </a:solidFill>
+                          <a:effectLst/>
+                          <a:latin typeface="+mn-lt"/>
+                        </a:rPr>
+                        <a:t>Linear Programming (LP) or MIP</a:t>
+                      </a:r>
+                    </a:p>
+                  </a:txBody>
+                  <a:tcPr anchor="ctr"/>
+                </a:tc>
+                <a:tc>
+                  <a:txBody>
+                    <a:bodyPr/>
+                    <a:lstStyle/>
+                    <a:p>
+                      <a:pPr>
+                        <a:buNone/>
+                      </a:pPr>
+                      <a:r>
+                        <a:rPr lang="en-IN" sz="1100">
+                          <a:solidFill>
+                            <a:srgbClr val="000000"/>
+                          </a:solidFill>
+                          <a:effectLst/>
+                          <a:latin typeface="+mn-lt"/>
+                        </a:rPr>
+                        <a:t>OR-Tools (SCIP or GLOP)</a:t>
+                      </a:r>
+                    </a:p>
+                  </a:txBody>
+                  <a:tcPr anchor="ctr"/>
+                </a:tc>
+                <a:tc>
+                  <a:txBody>
+                    <a:bodyPr/>
+                    <a:lstStyle/>
+                    <a:p>
+                      <a:pPr>
+                        <a:buNone/>
+                      </a:pPr>
+                      <a:r>
+                        <a:rPr lang="en-US" sz="1100">
+                          <a:solidFill>
+                            <a:srgbClr val="000000"/>
+                          </a:solidFill>
+                          <a:effectLst/>
+                          <a:latin typeface="+mn-lt"/>
+                        </a:rPr>
+                        <a:t>Minimizes node costs (e.g., preemptible VMs at ~80% discount) by assigning workloads to cost-efficient machine types, ensuring CPU/memory requirements and avoiding over-provisioning.</a:t>
+                      </a:r>
+                    </a:p>
+                  </a:txBody>
+                  <a:tcPr anchor="ctr"/>
+                </a:tc>
+                <a:extLst>
+                  <a:ext uri="{0D108BD9-81ED-4DB2-BD59-A6C34878D82A}">
+                    <a16:rowId xmlns:a16="http://schemas.microsoft.com/office/drawing/2014/main" val="1668825335"/>
+                  </a:ext>
+                </a:extLst>
+              </a:tr>
+              <a:tr h="370840">
+                <a:tc>
+                  <a:txBody>
+                    <a:bodyPr/>
+                    <a:lstStyle/>
+                    <a:p>
+                      <a:pPr>
+                        <a:buNone/>
+                      </a:pPr>
+                      <a:r>
+                        <a:rPr lang="en-IN" sz="1100">
+                          <a:solidFill>
+                            <a:srgbClr val="000000"/>
+                          </a:solidFill>
+                          <a:effectLst/>
+                          <a:latin typeface="+mn-lt"/>
+                        </a:rPr>
+                        <a:t>Compute Engine</a:t>
+                      </a:r>
+                    </a:p>
+                  </a:txBody>
+                  <a:tcPr anchor="ctr"/>
+                </a:tc>
+                <a:tc>
+                  <a:txBody>
+                    <a:bodyPr/>
+                    <a:lstStyle/>
+                    <a:p>
+                      <a:pPr>
+                        <a:buNone/>
+                      </a:pPr>
+                      <a:r>
+                        <a:rPr lang="en-US" sz="1100">
+                          <a:solidFill>
+                            <a:srgbClr val="000000"/>
+                          </a:solidFill>
+                          <a:effectLst/>
+                          <a:latin typeface="+mn-lt"/>
+                        </a:rPr>
+                        <a:t>Select optimal VM instance types (e.g., E2, N2, Compute-Optimized) and use sustained-use discounts or preemptible VMs for workloads to minimize compute costs.</a:t>
+                      </a:r>
+                    </a:p>
+                  </a:txBody>
+                  <a:tcPr anchor="ctr"/>
+                </a:tc>
+                <a:tc>
+                  <a:txBody>
+                    <a:bodyPr/>
+                    <a:lstStyle/>
+                    <a:p>
+                      <a:pPr>
+                        <a:buNone/>
+                      </a:pPr>
+                      <a:r>
+                        <a:rPr lang="en-IN" sz="1100">
+                          <a:solidFill>
+                            <a:srgbClr val="000000"/>
+                          </a:solidFill>
+                          <a:effectLst/>
+                          <a:latin typeface="+mn-lt"/>
+                        </a:rPr>
+                        <a:t>Mixed-Integer Programming (MIP)</a:t>
+                      </a:r>
+                    </a:p>
+                  </a:txBody>
+                  <a:tcPr anchor="ctr"/>
+                </a:tc>
+                <a:tc>
+                  <a:txBody>
+                    <a:bodyPr/>
+                    <a:lstStyle/>
+                    <a:p>
+                      <a:pPr>
+                        <a:buNone/>
+                      </a:pPr>
+                      <a:r>
+                        <a:rPr lang="en-IN" sz="1100">
+                          <a:solidFill>
+                            <a:srgbClr val="000000"/>
+                          </a:solidFill>
+                          <a:effectLst/>
+                          <a:latin typeface="+mn-lt"/>
+                        </a:rPr>
+                        <a:t>OR-Tools (SCIP)</a:t>
+                      </a:r>
+                    </a:p>
+                  </a:txBody>
+                  <a:tcPr anchor="ctr"/>
+                </a:tc>
+                <a:tc>
+                  <a:txBody>
+                    <a:bodyPr/>
+                    <a:lstStyle/>
+                    <a:p>
+                      <a:pPr>
+                        <a:buNone/>
+                      </a:pPr>
+                      <a:r>
+                        <a:rPr lang="en-US" sz="1100" dirty="0">
+                          <a:solidFill>
+                            <a:srgbClr val="000000"/>
+                          </a:solidFill>
+                          <a:effectLst/>
+                          <a:latin typeface="+mn-lt"/>
+                        </a:rPr>
+                        <a:t>Reduces costs by leveraging preemptible VMs (up to 80% cheaper) for fault-tolerant workloads and sustained-use discounts (up to 30%) for persistent VMs, matching resource needs to workload demands.</a:t>
+                      </a:r>
+                    </a:p>
+                  </a:txBody>
+                  <a:tcPr anchor="ctr"/>
+                </a:tc>
+                <a:extLst>
+                  <a:ext uri="{0D108BD9-81ED-4DB2-BD59-A6C34878D82A}">
+                    <a16:rowId xmlns:a16="http://schemas.microsoft.com/office/drawing/2014/main" val="2124909477"/>
+                  </a:ext>
+                </a:extLst>
+              </a:tr>
+            </a:tbl>
+          </a:graphicData>
+        </a:graphic>
+      </p:graphicFrame>
+    </p:spTree>
+    <p:extLst>
+      <p:ext uri="{BB962C8B-B14F-4D97-AF65-F5344CB8AC3E}">
+        <p14:creationId xmlns:p14="http://schemas.microsoft.com/office/powerpoint/2010/main" val="808407991"/>
+      </p:ext>
+    </p:extLst>
+  </p:cSld>
+  <p:clrMapOvr>
+    <a:masterClrMapping/>
+  </p:clrMapOvr>
+</p:sld>
+</file>
+
+<file path=ppt/slides/slide6.xml><?xml version="1.0" encoding="utf-8"?>
+<p:sld xmlns:a="http://schemas.openxmlformats.org/drawingml/2006/main" xmlns:r="http://schemas.openxmlformats.org/officeDocument/2006/relationships" xmlns:p="http://schemas.openxmlformats.org/presentationml/2006/main">
+  <p:cSld>
+    <p:spTree>
+      <p:nvGrpSpPr>
+        <p:cNvPr id="1" name="">
+          <a:extLst>
+            <a:ext uri="{FF2B5EF4-FFF2-40B4-BE49-F238E27FC236}">
+              <a16:creationId xmlns:a16="http://schemas.microsoft.com/office/drawing/2014/main" id="{6B68E093-43E4-6CE2-0ABD-1AAC709263FC}"/>
+            </a:ext>
+          </a:extLst>
+        </p:cNvPr>
+        <p:cNvGrpSpPr/>
+        <p:nvPr/>
+      </p:nvGrpSpPr>
+      <p:grpSpPr>
+        <a:xfrm>
+          <a:off x="0" y="0"/>
+          <a:ext cx="0" cy="0"/>
+          <a:chOff x="0" y="0"/>
+          <a:chExt cx="0" cy="0"/>
+        </a:xfrm>
+      </p:grpSpPr>
+      <p:sp>
+        <p:nvSpPr>
+          <p:cNvPr id="2" name="Title 1">
+            <a:extLst>
+              <a:ext uri="{FF2B5EF4-FFF2-40B4-BE49-F238E27FC236}">
+                <a16:creationId xmlns:a16="http://schemas.microsoft.com/office/drawing/2014/main" id="{2C4D57BC-D093-76FA-8830-40FC806789EE}"/>
+              </a:ext>
+            </a:extLst>
+          </p:cNvPr>
+          <p:cNvSpPr>
+            <a:spLocks noGrp="1"/>
+          </p:cNvSpPr>
+          <p:nvPr>
+            <p:ph type="title"/>
+          </p:nvPr>
+        </p:nvSpPr>
+        <p:spPr>
+          <a:xfrm>
+            <a:off x="765048" y="376393"/>
+            <a:ext cx="10515600" cy="348107"/>
+          </a:xfrm>
+        </p:spPr>
+        <p:txBody>
+          <a:bodyPr>
+            <a:normAutofit/>
+          </a:bodyPr>
+          <a:lstStyle/>
+          <a:p>
+            <a:r>
+              <a:rPr lang="en-IN" sz="1800" b="1" dirty="0">
+                <a:latin typeface="+mn-lt"/>
+              </a:rPr>
+              <a:t>GCP services cost optimization use cases with example</a:t>
+            </a:r>
+          </a:p>
+        </p:txBody>
+      </p:sp>
+      <p:graphicFrame>
+        <p:nvGraphicFramePr>
+          <p:cNvPr id="6" name="Content Placeholder 5">
+            <a:extLst>
+              <a:ext uri="{FF2B5EF4-FFF2-40B4-BE49-F238E27FC236}">
+                <a16:creationId xmlns:a16="http://schemas.microsoft.com/office/drawing/2014/main" id="{0CA6EE33-E860-095C-63FA-C49E0CC6AB7B}"/>
+              </a:ext>
+            </a:extLst>
+          </p:cNvPr>
+          <p:cNvGraphicFramePr>
+            <a:graphicFrameLocks noGrp="1"/>
+          </p:cNvGraphicFramePr>
+          <p:nvPr>
+            <p:ph idx="1"/>
+            <p:extLst>
+              <p:ext uri="{D42A27DB-BD31-4B8C-83A1-F6EECF244321}">
+                <p14:modId xmlns:p14="http://schemas.microsoft.com/office/powerpoint/2010/main" val="1722250872"/>
+              </p:ext>
+            </p:extLst>
+          </p:nvPr>
+        </p:nvGraphicFramePr>
+        <p:xfrm>
+          <a:off x="804672" y="827567"/>
+          <a:ext cx="10582655" cy="5125720"/>
+        </p:xfrm>
+        <a:graphic>
+          <a:graphicData uri="http://schemas.openxmlformats.org/drawingml/2006/table">
+            <a:tbl>
+              <a:tblPr firstRow="1" bandRow="1">
+                <a:tableStyleId>{5C22544A-7EE6-4342-B048-85BDC9FD1C3A}</a:tableStyleId>
+              </a:tblPr>
+              <a:tblGrid>
+                <a:gridCol w="2116531">
+                  <a:extLst>
+                    <a:ext uri="{9D8B030D-6E8A-4147-A177-3AD203B41FA5}">
+                      <a16:colId xmlns:a16="http://schemas.microsoft.com/office/drawing/2014/main" val="3960887689"/>
+                    </a:ext>
+                  </a:extLst>
+                </a:gridCol>
+                <a:gridCol w="2116531">
+                  <a:extLst>
+                    <a:ext uri="{9D8B030D-6E8A-4147-A177-3AD203B41FA5}">
+                      <a16:colId xmlns:a16="http://schemas.microsoft.com/office/drawing/2014/main" val="739127273"/>
+                    </a:ext>
+                  </a:extLst>
+                </a:gridCol>
+                <a:gridCol w="2116531">
+                  <a:extLst>
+                    <a:ext uri="{9D8B030D-6E8A-4147-A177-3AD203B41FA5}">
+                      <a16:colId xmlns:a16="http://schemas.microsoft.com/office/drawing/2014/main" val="1537214704"/>
+                    </a:ext>
+                  </a:extLst>
+                </a:gridCol>
+                <a:gridCol w="2116531">
+                  <a:extLst>
+                    <a:ext uri="{9D8B030D-6E8A-4147-A177-3AD203B41FA5}">
+                      <a16:colId xmlns:a16="http://schemas.microsoft.com/office/drawing/2014/main" val="3492142327"/>
+                    </a:ext>
+                  </a:extLst>
+                </a:gridCol>
+                <a:gridCol w="2116531">
+                  <a:extLst>
+                    <a:ext uri="{9D8B030D-6E8A-4147-A177-3AD203B41FA5}">
+                      <a16:colId xmlns:a16="http://schemas.microsoft.com/office/drawing/2014/main" val="3459181092"/>
+                    </a:ext>
+                  </a:extLst>
+                </a:gridCol>
+              </a:tblGrid>
+              <a:tr h="370840">
+                <a:tc>
+                  <a:txBody>
+                    <a:bodyPr/>
+                    <a:lstStyle/>
+                    <a:p>
+                      <a:pPr>
+                        <a:buNone/>
+                      </a:pPr>
+                      <a:r>
+                        <a:rPr lang="en-IN" sz="1200" b="1">
+                          <a:solidFill>
+                            <a:srgbClr val="000000"/>
+                          </a:solidFill>
+                          <a:effectLst/>
+                          <a:latin typeface="+mn-lt"/>
+                        </a:rPr>
+                        <a:t>Programming Type</a:t>
+                      </a:r>
+                    </a:p>
+                  </a:txBody>
+                  <a:tcPr anchor="ctr"/>
+                </a:tc>
+                <a:tc>
+                  <a:txBody>
+                    <a:bodyPr/>
+                    <a:lstStyle/>
+                    <a:p>
+                      <a:pPr>
+                        <a:buNone/>
+                      </a:pPr>
+                      <a:r>
+                        <a:rPr lang="en-IN" sz="1200" b="1">
+                          <a:solidFill>
+                            <a:srgbClr val="000000"/>
+                          </a:solidFill>
+                          <a:effectLst/>
+                          <a:latin typeface="+mn-lt"/>
+                        </a:rPr>
+                        <a:t>Simple Explanation</a:t>
+                      </a:r>
+                    </a:p>
+                  </a:txBody>
+                  <a:tcPr anchor="ctr"/>
+                </a:tc>
+                <a:tc>
+                  <a:txBody>
+                    <a:bodyPr/>
+                    <a:lstStyle/>
+                    <a:p>
+                      <a:pPr>
+                        <a:buNone/>
+                      </a:pPr>
+                      <a:r>
+                        <a:rPr lang="en-IN" sz="1200" b="1">
+                          <a:solidFill>
+                            <a:srgbClr val="000000"/>
+                          </a:solidFill>
+                          <a:effectLst/>
+                          <a:latin typeface="+mn-lt"/>
+                        </a:rPr>
+                        <a:t>How It Works</a:t>
+                      </a:r>
+                    </a:p>
+                  </a:txBody>
+                  <a:tcPr anchor="ctr"/>
+                </a:tc>
+                <a:tc>
+                  <a:txBody>
+                    <a:bodyPr/>
+                    <a:lstStyle/>
+                    <a:p>
+                      <a:pPr>
+                        <a:buNone/>
+                      </a:pPr>
+                      <a:r>
+                        <a:rPr lang="en-IN" sz="1200" b="1">
+                          <a:solidFill>
+                            <a:srgbClr val="000000"/>
+                          </a:solidFill>
+                          <a:effectLst/>
+                          <a:latin typeface="+mn-lt"/>
+                        </a:rPr>
+                        <a:t>Example Use Case</a:t>
+                      </a:r>
+                    </a:p>
+                  </a:txBody>
+                  <a:tcPr anchor="ctr"/>
+                </a:tc>
+                <a:tc>
+                  <a:txBody>
+                    <a:bodyPr/>
+                    <a:lstStyle/>
+                    <a:p>
+                      <a:pPr>
+                        <a:buNone/>
+                      </a:pPr>
+                      <a:r>
+                        <a:rPr lang="en-IN" sz="1200" b="1">
+                          <a:solidFill>
+                            <a:srgbClr val="000000"/>
+                          </a:solidFill>
+                          <a:effectLst/>
+                          <a:latin typeface="+mn-lt"/>
+                        </a:rPr>
+                        <a:t>Why Use It?</a:t>
+                      </a:r>
+                    </a:p>
+                  </a:txBody>
+                  <a:tcPr anchor="ctr"/>
+                </a:tc>
+                <a:extLst>
+                  <a:ext uri="{0D108BD9-81ED-4DB2-BD59-A6C34878D82A}">
+                    <a16:rowId xmlns:a16="http://schemas.microsoft.com/office/drawing/2014/main" val="1963196394"/>
+                  </a:ext>
+                </a:extLst>
+              </a:tr>
+              <a:tr h="370840">
+                <a:tc>
+                  <a:txBody>
+                    <a:bodyPr/>
+                    <a:lstStyle/>
+                    <a:p>
+                      <a:pPr>
+                        <a:buNone/>
+                      </a:pPr>
+                      <a:r>
+                        <a:rPr lang="en-IN" sz="1200">
+                          <a:solidFill>
+                            <a:srgbClr val="000000"/>
+                          </a:solidFill>
+                          <a:effectLst/>
+                          <a:latin typeface="+mn-lt"/>
+                        </a:rPr>
+                        <a:t>Linear Programming (LP)</a:t>
+                      </a:r>
+                    </a:p>
+                  </a:txBody>
+                  <a:tcPr anchor="ctr"/>
+                </a:tc>
+                <a:tc>
+                  <a:txBody>
+                    <a:bodyPr/>
+                    <a:lstStyle/>
+                    <a:p>
+                      <a:pPr>
+                        <a:buNone/>
+                      </a:pPr>
+                      <a:r>
+                        <a:rPr lang="en-US" sz="1200">
+                          <a:solidFill>
+                            <a:srgbClr val="000000"/>
+                          </a:solidFill>
+                          <a:effectLst/>
+                          <a:latin typeface="+mn-lt"/>
+                        </a:rPr>
+                        <a:t>Finds the best solution (e.g., lowest cost) for problems with continuous variables, like how much of something to use, under constraints like budget or resources.</a:t>
+                      </a:r>
+                    </a:p>
+                  </a:txBody>
+                  <a:tcPr anchor="ctr"/>
+                </a:tc>
+                <a:tc>
+                  <a:txBody>
+                    <a:bodyPr/>
+                    <a:lstStyle/>
+                    <a:p>
+                      <a:pPr>
+                        <a:buNone/>
+                      </a:pPr>
+                      <a:r>
+                        <a:rPr lang="en-US" sz="1200">
+                          <a:solidFill>
+                            <a:srgbClr val="000000"/>
+                          </a:solidFill>
+                          <a:effectLst/>
+                          <a:latin typeface="+mn-lt"/>
+                        </a:rPr>
+                        <a:t>Uses equations where variables (e.g., resource amounts) can be any number (not just whole numbers) and optimizes a goal (e.g., minimize cost). Constraints are limits like storage capacity.</a:t>
+                      </a:r>
+                    </a:p>
+                  </a:txBody>
+                  <a:tcPr anchor="ctr"/>
+                </a:tc>
+                <a:tc>
+                  <a:txBody>
+                    <a:bodyPr/>
+                    <a:lstStyle/>
+                    <a:p>
+                      <a:pPr>
+                        <a:buNone/>
+                      </a:pPr>
+                      <a:r>
+                        <a:rPr lang="en-US" sz="1200">
+                          <a:solidFill>
+                            <a:srgbClr val="000000"/>
+                          </a:solidFill>
+                          <a:effectLst/>
+                          <a:latin typeface="+mn-lt"/>
+                        </a:rPr>
+                        <a:t>Optimize Cloud Dataflow worker usage to minimize compute costs while meeting job deadlines (e.g., scale workers to process 2 TB data).</a:t>
+                      </a:r>
+                    </a:p>
+                  </a:txBody>
+                  <a:tcPr anchor="ctr"/>
+                </a:tc>
+                <a:tc>
+                  <a:txBody>
+                    <a:bodyPr/>
+                    <a:lstStyle/>
+                    <a:p>
+                      <a:pPr>
+                        <a:buNone/>
+                      </a:pPr>
+                      <a:r>
+                        <a:rPr lang="en-US" sz="1200">
+                          <a:solidFill>
+                            <a:srgbClr val="000000"/>
+                          </a:solidFill>
+                          <a:effectLst/>
+                          <a:latin typeface="+mn-lt"/>
+                        </a:rPr>
+                        <a:t>Simple and fast for problems with smooth, continuous choices, like scaling resources or allocating budgets.</a:t>
+                      </a:r>
+                    </a:p>
+                  </a:txBody>
+                  <a:tcPr anchor="ctr"/>
+                </a:tc>
+                <a:extLst>
+                  <a:ext uri="{0D108BD9-81ED-4DB2-BD59-A6C34878D82A}">
+                    <a16:rowId xmlns:a16="http://schemas.microsoft.com/office/drawing/2014/main" val="1904820983"/>
+                  </a:ext>
+                </a:extLst>
+              </a:tr>
+              <a:tr h="370840">
+                <a:tc>
+                  <a:txBody>
+                    <a:bodyPr/>
+                    <a:lstStyle/>
+                    <a:p>
+                      <a:pPr>
+                        <a:buNone/>
+                      </a:pPr>
+                      <a:r>
+                        <a:rPr lang="en-IN" sz="1200">
+                          <a:solidFill>
+                            <a:srgbClr val="000000"/>
+                          </a:solidFill>
+                          <a:effectLst/>
+                          <a:latin typeface="+mn-lt"/>
+                        </a:rPr>
+                        <a:t>Mixed-Integer Programming (MIP)</a:t>
+                      </a:r>
+                    </a:p>
+                  </a:txBody>
+                  <a:tcPr anchor="ctr"/>
+                </a:tc>
+                <a:tc>
+                  <a:txBody>
+                    <a:bodyPr/>
+                    <a:lstStyle/>
+                    <a:p>
+                      <a:pPr>
+                        <a:buNone/>
+                      </a:pPr>
+                      <a:r>
+                        <a:rPr lang="en-US" sz="1200">
+                          <a:solidFill>
+                            <a:srgbClr val="000000"/>
+                          </a:solidFill>
+                          <a:effectLst/>
+                          <a:latin typeface="+mn-lt"/>
+                        </a:rPr>
+                        <a:t>Similar to LP, but some variables must be whole numbers (e.g., number of VMs). Used for problems with both continuous and discrete choices.</a:t>
+                      </a:r>
+                    </a:p>
+                  </a:txBody>
+                  <a:tcPr anchor="ctr"/>
+                </a:tc>
+                <a:tc>
+                  <a:txBody>
+                    <a:bodyPr/>
+                    <a:lstStyle/>
+                    <a:p>
+                      <a:pPr>
+                        <a:buNone/>
+                      </a:pPr>
+                      <a:r>
+                        <a:rPr lang="en-US" sz="1200">
+                          <a:solidFill>
+                            <a:srgbClr val="000000"/>
+                          </a:solidFill>
+                          <a:effectLst/>
+                          <a:latin typeface="+mn-lt"/>
+                        </a:rPr>
+                        <a:t>Combines LP with integer constraints. Solves problems where decisions include "how many" (e.g., VMs) and "how much" (e.g., storage size).</a:t>
+                      </a:r>
+                    </a:p>
+                  </a:txBody>
+                  <a:tcPr anchor="ctr"/>
+                </a:tc>
+                <a:tc>
+                  <a:txBody>
+                    <a:bodyPr/>
+                    <a:lstStyle/>
+                    <a:p>
+                      <a:pPr>
+                        <a:buNone/>
+                      </a:pPr>
+                      <a:r>
+                        <a:rPr lang="en-US" sz="1200">
+                          <a:solidFill>
+                            <a:srgbClr val="000000"/>
+                          </a:solidFill>
+                          <a:effectLst/>
+                          <a:latin typeface="+mn-lt"/>
+                        </a:rPr>
+                        <a:t>Assign BigQuery datasets to active or long-term storage and choose on-demand or flat-rate slots to minimize costs.</a:t>
+                      </a:r>
+                    </a:p>
+                  </a:txBody>
+                  <a:tcPr anchor="ctr"/>
+                </a:tc>
+                <a:tc>
+                  <a:txBody>
+                    <a:bodyPr/>
+                    <a:lstStyle/>
+                    <a:p>
+                      <a:pPr>
+                        <a:buNone/>
+                      </a:pPr>
+                      <a:r>
+                        <a:rPr lang="en-US" sz="1200">
+                          <a:solidFill>
+                            <a:srgbClr val="000000"/>
+                          </a:solidFill>
+                          <a:effectLst/>
+                          <a:latin typeface="+mn-lt"/>
+                        </a:rPr>
+                        <a:t>Handles complex decisions with both whole-number and fractional variables, like choosing machine types and resource amounts.</a:t>
+                      </a:r>
+                    </a:p>
+                  </a:txBody>
+                  <a:tcPr anchor="ctr"/>
+                </a:tc>
+                <a:extLst>
+                  <a:ext uri="{0D108BD9-81ED-4DB2-BD59-A6C34878D82A}">
+                    <a16:rowId xmlns:a16="http://schemas.microsoft.com/office/drawing/2014/main" val="3933942296"/>
+                  </a:ext>
+                </a:extLst>
+              </a:tr>
+              <a:tr h="370840">
+                <a:tc>
+                  <a:txBody>
+                    <a:bodyPr/>
+                    <a:lstStyle/>
+                    <a:p>
+                      <a:pPr>
+                        <a:buNone/>
+                      </a:pPr>
+                      <a:r>
+                        <a:rPr lang="en-IN" sz="1200">
+                          <a:solidFill>
+                            <a:srgbClr val="000000"/>
+                          </a:solidFill>
+                          <a:effectLst/>
+                          <a:latin typeface="+mn-lt"/>
+                        </a:rPr>
+                        <a:t>Integer Programming (IP)</a:t>
+                      </a:r>
+                    </a:p>
+                  </a:txBody>
+                  <a:tcPr anchor="ctr"/>
+                </a:tc>
+                <a:tc>
+                  <a:txBody>
+                    <a:bodyPr/>
+                    <a:lstStyle/>
+                    <a:p>
+                      <a:pPr>
+                        <a:buNone/>
+                      </a:pPr>
+                      <a:r>
+                        <a:rPr lang="en-US" sz="1200">
+                          <a:solidFill>
+                            <a:srgbClr val="000000"/>
+                          </a:solidFill>
+                          <a:effectLst/>
+                          <a:latin typeface="+mn-lt"/>
+                        </a:rPr>
+                        <a:t>Finds the best solution when all decision variables must be whole numbers, like choosing specific items or quantities.</a:t>
+                      </a:r>
+                    </a:p>
+                  </a:txBody>
+                  <a:tcPr anchor="ctr"/>
+                </a:tc>
+                <a:tc>
+                  <a:txBody>
+                    <a:bodyPr/>
+                    <a:lstStyle/>
+                    <a:p>
+                      <a:pPr>
+                        <a:buNone/>
+                      </a:pPr>
+                      <a:r>
+                        <a:rPr lang="en-US" sz="1200">
+                          <a:solidFill>
+                            <a:srgbClr val="000000"/>
+                          </a:solidFill>
+                          <a:effectLst/>
+                          <a:latin typeface="+mn-lt"/>
+                        </a:rPr>
+                        <a:t>Like MIP, but all variables are integers (no fractions). Useful for yes/no decisions or counting items.</a:t>
+                      </a:r>
+                    </a:p>
+                  </a:txBody>
+                  <a:tcPr anchor="ctr"/>
+                </a:tc>
+                <a:tc>
+                  <a:txBody>
+                    <a:bodyPr/>
+                    <a:lstStyle/>
+                    <a:p>
+                      <a:pPr>
+                        <a:buNone/>
+                      </a:pPr>
+                      <a:r>
+                        <a:rPr lang="en-US" sz="1200">
+                          <a:solidFill>
+                            <a:srgbClr val="000000"/>
+                          </a:solidFill>
+                          <a:effectLst/>
+                          <a:latin typeface="+mn-lt"/>
+                        </a:rPr>
+                        <a:t>Select the number of Compute Engine VMs (e.g., 5 E2 instances) to minimize costs while meeting workload demands.</a:t>
+                      </a:r>
+                    </a:p>
+                  </a:txBody>
+                  <a:tcPr anchor="ctr"/>
+                </a:tc>
+                <a:tc>
+                  <a:txBody>
+                    <a:bodyPr/>
+                    <a:lstStyle/>
+                    <a:p>
+                      <a:pPr>
+                        <a:buNone/>
+                      </a:pPr>
+                      <a:r>
+                        <a:rPr lang="en-US" sz="1200">
+                          <a:solidFill>
+                            <a:srgbClr val="000000"/>
+                          </a:solidFill>
+                          <a:effectLst/>
+                          <a:latin typeface="+mn-lt"/>
+                        </a:rPr>
+                        <a:t>Ideal for problems where decisions are discrete, like picking specific resources or configurations.</a:t>
+                      </a:r>
+                    </a:p>
+                  </a:txBody>
+                  <a:tcPr anchor="ctr"/>
+                </a:tc>
+                <a:extLst>
+                  <a:ext uri="{0D108BD9-81ED-4DB2-BD59-A6C34878D82A}">
+                    <a16:rowId xmlns:a16="http://schemas.microsoft.com/office/drawing/2014/main" val="1668825335"/>
+                  </a:ext>
+                </a:extLst>
+              </a:tr>
+              <a:tr h="370840">
+                <a:tc>
+                  <a:txBody>
+                    <a:bodyPr/>
+                    <a:lstStyle/>
+                    <a:p>
+                      <a:pPr>
+                        <a:buNone/>
+                      </a:pPr>
+                      <a:r>
+                        <a:rPr lang="en-IN" sz="1200">
+                          <a:solidFill>
+                            <a:srgbClr val="000000"/>
+                          </a:solidFill>
+                          <a:effectLst/>
+                          <a:latin typeface="+mn-lt"/>
+                        </a:rPr>
+                        <a:t>Constraint Programming (CP)</a:t>
+                      </a:r>
+                    </a:p>
+                  </a:txBody>
+                  <a:tcPr anchor="ctr"/>
+                </a:tc>
+                <a:tc>
+                  <a:txBody>
+                    <a:bodyPr/>
+                    <a:lstStyle/>
+                    <a:p>
+                      <a:pPr>
+                        <a:buNone/>
+                      </a:pPr>
+                      <a:r>
+                        <a:rPr lang="en-US" sz="1200">
+                          <a:solidFill>
+                            <a:srgbClr val="000000"/>
+                          </a:solidFill>
+                          <a:effectLst/>
+                          <a:latin typeface="+mn-lt"/>
+                        </a:rPr>
+                        <a:t>Solves problems by defining rules (constraints) that solutions must follow, like scheduling or resource allocation, without necessarily optimizing a single goal.</a:t>
+                      </a:r>
+                    </a:p>
+                  </a:txBody>
+                  <a:tcPr anchor="ctr"/>
+                </a:tc>
+                <a:tc>
+                  <a:txBody>
+                    <a:bodyPr/>
+                    <a:lstStyle/>
+                    <a:p>
+                      <a:pPr>
+                        <a:buNone/>
+                      </a:pPr>
+                      <a:r>
+                        <a:rPr lang="en-US" sz="1200">
+                          <a:solidFill>
+                            <a:srgbClr val="000000"/>
+                          </a:solidFill>
+                          <a:effectLst/>
+                          <a:latin typeface="+mn-lt"/>
+                        </a:rPr>
+                        <a:t>Finds feasible solutions that satisfy all constraints (e.g., task deadlines, resource limits). Can optimize a goal if needed.</a:t>
+                      </a:r>
+                    </a:p>
+                  </a:txBody>
+                  <a:tcPr anchor="ctr"/>
+                </a:tc>
+                <a:tc>
+                  <a:txBody>
+                    <a:bodyPr/>
+                    <a:lstStyle/>
+                    <a:p>
+                      <a:pPr>
+                        <a:buNone/>
+                      </a:pPr>
+                      <a:r>
+                        <a:rPr lang="en-US" sz="1200">
+                          <a:solidFill>
+                            <a:srgbClr val="000000"/>
+                          </a:solidFill>
+                          <a:effectLst/>
+                          <a:latin typeface="+mn-lt"/>
+                        </a:rPr>
+                        <a:t>Schedule GKE workloads across nodes to balance CPU/memory usage while respecting pod requirements.</a:t>
+                      </a:r>
+                    </a:p>
+                  </a:txBody>
+                  <a:tcPr anchor="ctr"/>
+                </a:tc>
+                <a:tc>
+                  <a:txBody>
+                    <a:bodyPr/>
+                    <a:lstStyle/>
+                    <a:p>
+                      <a:pPr>
+                        <a:buNone/>
+                      </a:pPr>
+                      <a:r>
+                        <a:rPr lang="en-US" sz="1200" dirty="0">
+                          <a:solidFill>
+                            <a:srgbClr val="000000"/>
+                          </a:solidFill>
+                          <a:effectLst/>
+                          <a:latin typeface="+mn-lt"/>
+                        </a:rPr>
+                        <a:t>Flexible for complex rule-based problems, like scheduling or assigning tasks without a single cost focus.</a:t>
+                      </a:r>
+                    </a:p>
+                  </a:txBody>
+                  <a:tcPr anchor="ctr"/>
+                </a:tc>
+                <a:extLst>
+                  <a:ext uri="{0D108BD9-81ED-4DB2-BD59-A6C34878D82A}">
+                    <a16:rowId xmlns:a16="http://schemas.microsoft.com/office/drawing/2014/main" val="2124909477"/>
+                  </a:ext>
+                </a:extLst>
+              </a:tr>
+            </a:tbl>
+          </a:graphicData>
+        </a:graphic>
+      </p:graphicFrame>
+    </p:spTree>
+    <p:extLst>
+      <p:ext uri="{BB962C8B-B14F-4D97-AF65-F5344CB8AC3E}">
+        <p14:creationId xmlns:p14="http://schemas.microsoft.com/office/powerpoint/2010/main" val="2029313500"/>
+      </p:ext>
+    </p:extLst>
+  </p:cSld>
+  <p:clrMapOvr>
+    <a:masterClrMapping/>
+  </p:clrMapOvr>
+</p:sld>
+</file>
+
+<file path=ppt/slides/slide7.xml><?xml version="1.0" encoding="utf-8"?>
+<p:sld xmlns:a="http://schemas.openxmlformats.org/drawingml/2006/main" xmlns:r="http://schemas.openxmlformats.org/officeDocument/2006/relationships" xmlns:p="http://schemas.openxmlformats.org/presentationml/2006/main">
+  <p:cSld>
+    <p:spTree>
+      <p:nvGrpSpPr>
+        <p:cNvPr id="1" name=""/>
+        <p:cNvGrpSpPr/>
+        <p:nvPr/>
+      </p:nvGrpSpPr>
+      <p:grpSpPr>
+        <a:xfrm>
+          <a:off x="0" y="0"/>
+          <a:ext cx="0" cy="0"/>
+          <a:chOff x="0" y="0"/>
+          <a:chExt cx="0" cy="0"/>
+        </a:xfrm>
+      </p:grpSpPr>
+      <p:pic>
+        <p:nvPicPr>
+          <p:cNvPr id="17" name="Content Placeholder 16">
+            <a:extLst>
+              <a:ext uri="{FF2B5EF4-FFF2-40B4-BE49-F238E27FC236}">
+                <a16:creationId xmlns:a16="http://schemas.microsoft.com/office/drawing/2014/main" id="{DD67A9E8-643F-2FB6-C772-78E51E063A66}"/>
+              </a:ext>
+            </a:extLst>
+          </p:cNvPr>
+          <p:cNvPicPr>
+            <a:picLocks noGrp="1" noChangeAspect="1"/>
+          </p:cNvPicPr>
+          <p:nvPr>
+            <p:ph idx="1"/>
+          </p:nvPr>
+        </p:nvPicPr>
+        <p:blipFill>
+          <a:blip r:embed="rId2">
+            <a:extLst>
+              <a:ext uri="{28A0092B-C50C-407E-A947-70E740481C1C}">
+                <a14:useLocalDpi xmlns:a14="http://schemas.microsoft.com/office/drawing/2010/main" val="0"/>
+              </a:ext>
+            </a:extLst>
+          </a:blip>
+          <a:stretch>
+            <a:fillRect/>
+          </a:stretch>
+        </p:blipFill>
+        <p:spPr>
+          <a:xfrm>
+            <a:off x="1413301" y="316864"/>
+            <a:ext cx="9010859" cy="6176757"/>
+          </a:xfrm>
+        </p:spPr>
+      </p:pic>
+    </p:spTree>
+    <p:extLst>
+      <p:ext uri="{BB962C8B-B14F-4D97-AF65-F5344CB8AC3E}">
+        <p14:creationId xmlns:p14="http://schemas.microsoft.com/office/powerpoint/2010/main" val="1141578311"/>
+      </p:ext>
+    </p:extLst>
+  </p:cSld>
+  <p:clrMapOvr>
+    <a:masterClrMapping/>
+  </p:clrMapOvr>
+</p:sld>
+</file>
+
 <file path=ppt/theme/theme1.xml><?xml version="1.0" encoding="utf-8"?>
 <a:theme xmlns:a="http://schemas.openxmlformats.org/drawingml/2006/main" name="Office Theme">
   <a:themeElements>

</xml_diff>